<commit_message>
Build tooling: multi-line and bar charts, more slide layouts, week-specific data loading
</commit_message>
<xml_diff>
--- a/Jasons-Restructure/week-1/day-1-colab-and-your-first-time-series/1-slides/powerpoint/W1D1-slides.pptx
+++ b/Jasons-Restructure/week-1/day-1-colab-and-your-first-time-series/1-slides/powerpoint/W1D1-slides.pptx
@@ -1062,7 +1062,7 @@
               <c:strCache>
                 <c:ptCount val="1"/>
                 <c:pt idx="0">
-                  <c:v>availability %</c:v>
+                  <c:v>value</c:v>
                 </c:pt>
               </c:strCache>
             </c:strRef>
@@ -4871,7 +4871,7 @@
       </p:sp>
       <p:sp>
         <p:nvSpPr>
-          <p:cNvPr id="3" name="ordered card"/>
+          <p:cNvPr id="3" name="left card"/>
           <p:cNvSpPr/>
           <p:nvPr/>
         </p:nvSpPr>
@@ -4934,7 +4934,7 @@
       </p:sp>
       <p:graphicFrame>
         <p:nvGraphicFramePr>
-          <p:cNvPr id="5" name="ordered chart" descr=""/>
+          <p:cNvPr id="5" name="left chart" descr=""/>
           <p:cNvGraphicFramePr/>
           <p:nvPr/>
         </p:nvGraphicFramePr>
@@ -4950,7 +4950,7 @@
       </p:graphicFrame>
       <p:sp>
         <p:nvSpPr>
-          <p:cNvPr id="6" name="shuffled card"/>
+          <p:cNvPr id="6" name="right card"/>
           <p:cNvSpPr/>
           <p:nvPr/>
         </p:nvSpPr>
@@ -5013,7 +5013,7 @@
       </p:sp>
       <p:graphicFrame>
         <p:nvGraphicFramePr>
-          <p:cNvPr id="8" name="shuffled chart" descr=""/>
+          <p:cNvPr id="8" name="right chart" descr=""/>
           <p:cNvGraphicFramePr/>
           <p:nvPr/>
         </p:nvGraphicFramePr>

</xml_diff>